<commit_message>
contents 및 Git roadmap 제작 동기
</commit_message>
<xml_diff>
--- a/gitroadmap.pptx
+++ b/gitroadmap.pptx
@@ -7,6 +7,9 @@
   <p:sldIdLst>
     <p:sldId id="256" r:id="rId2"/>
     <p:sldId id="257" r:id="rId3"/>
+    <p:sldId id="258" r:id="rId4"/>
+    <p:sldId id="259" r:id="rId5"/>
+    <p:sldId id="260" r:id="rId6"/>
   </p:sldIdLst>
   <p:sldSz cx="12192000" cy="6858000"/>
   <p:notesSz cx="6858000" cy="9144000"/>
@@ -2746,9 +2749,12 @@
 <p:sldMaster xmlns:a="http://schemas.openxmlformats.org/drawingml/2006/main" xmlns:r="http://schemas.openxmlformats.org/officeDocument/2006/relationships" xmlns:p="http://schemas.openxmlformats.org/presentationml/2006/main">
   <p:cSld>
     <p:bg>
-      <p:bgRef idx="1001">
-        <a:schemeClr val="bg1"/>
-      </p:bgRef>
+      <p:bgPr>
+        <a:solidFill>
+          <a:srgbClr val="EEEEE6"/>
+        </a:solidFill>
+        <a:effectLst/>
+      </p:bgPr>
     </p:bg>
     <p:spTree>
       <p:nvGrpSpPr>
@@ -3313,14 +3319,6 @@
 <file path=ppt/slides/slide1.xml><?xml version="1.0" encoding="utf-8"?>
 <p:sld xmlns:a="http://schemas.openxmlformats.org/drawingml/2006/main" xmlns:r="http://schemas.openxmlformats.org/officeDocument/2006/relationships" xmlns:p="http://schemas.openxmlformats.org/presentationml/2006/main">
   <p:cSld>
-    <p:bg>
-      <p:bgPr>
-        <a:solidFill>
-          <a:schemeClr val="bg1"/>
-        </a:solidFill>
-        <a:effectLst/>
-      </p:bgPr>
-    </p:bg>
     <p:spTree>
       <p:nvGrpSpPr>
         <p:cNvPr id="1" name=""/>
@@ -3895,6 +3893,103 @@
       </p:grpSpPr>
       <p:sp>
         <p:nvSpPr>
+          <p:cNvPr id="26" name="사각형: 둥근 모서리 25">
+            <a:extLst>
+              <a:ext uri="{FF2B5EF4-FFF2-40B4-BE49-F238E27FC236}">
+                <a16:creationId xmlns:a16="http://schemas.microsoft.com/office/drawing/2014/main" id="{4CF51C5B-A44C-4AA7-ABD8-1D26ADD8AAD3}"/>
+              </a:ext>
+            </a:extLst>
+          </p:cNvPr>
+          <p:cNvSpPr/>
+          <p:nvPr/>
+        </p:nvSpPr>
+        <p:spPr>
+          <a:xfrm>
+            <a:off x="626165" y="408841"/>
+            <a:ext cx="11221278" cy="6280194"/>
+          </a:xfrm>
+          <a:prstGeom prst="roundRect">
+            <a:avLst>
+              <a:gd name="adj" fmla="val 4717"/>
+            </a:avLst>
+          </a:prstGeom>
+          <a:solidFill>
+            <a:schemeClr val="bg1">
+              <a:alpha val="74000"/>
+            </a:schemeClr>
+          </a:solidFill>
+          <a:ln>
+            <a:noFill/>
+          </a:ln>
+        </p:spPr>
+        <p:style>
+          <a:lnRef idx="2">
+            <a:schemeClr val="accent1">
+              <a:shade val="50000"/>
+            </a:schemeClr>
+          </a:lnRef>
+          <a:fillRef idx="1">
+            <a:schemeClr val="accent1"/>
+          </a:fillRef>
+          <a:effectRef idx="0">
+            <a:schemeClr val="accent1"/>
+          </a:effectRef>
+          <a:fontRef idx="minor">
+            <a:schemeClr val="lt1"/>
+          </a:fontRef>
+        </p:style>
+        <p:txBody>
+          <a:bodyPr rtlCol="0" anchor="ctr"/>
+          <a:lstStyle/>
+          <a:p>
+            <a:pPr algn="ctr"/>
+            <a:endParaRPr lang="ko-KR" altLang="en-US"/>
+          </a:p>
+        </p:txBody>
+      </p:sp>
+      <p:pic>
+        <p:nvPicPr>
+          <p:cNvPr id="23" name="그래픽 22">
+            <a:extLst>
+              <a:ext uri="{FF2B5EF4-FFF2-40B4-BE49-F238E27FC236}">
+                <a16:creationId xmlns:a16="http://schemas.microsoft.com/office/drawing/2014/main" id="{C0B92B87-B9F8-48A2-89FD-FC5A3FB3A500}"/>
+              </a:ext>
+            </a:extLst>
+          </p:cNvPr>
+          <p:cNvPicPr>
+            <a:picLocks noChangeAspect="1"/>
+          </p:cNvPicPr>
+          <p:nvPr/>
+        </p:nvPicPr>
+        <p:blipFill>
+          <a:blip r:embed="rId2">
+            <a:lum bright="44000"/>
+            <a:alphaModFix/>
+            <a:extLst>
+              <a:ext uri="{28A0092B-C50C-407E-A947-70E740481C1C}">
+                <a14:useLocalDpi xmlns:a14="http://schemas.microsoft.com/office/drawing/2010/main" val="0"/>
+              </a:ext>
+              <a:ext uri="{96DAC541-7B7A-43D3-8B79-37D633B846F1}">
+                <asvg:svgBlip xmlns:asvg="http://schemas.microsoft.com/office/drawing/2016/SVG/main" r:embed="rId3"/>
+              </a:ext>
+            </a:extLst>
+          </a:blip>
+          <a:stretch>
+            <a:fillRect/>
+          </a:stretch>
+        </p:blipFill>
+        <p:spPr>
+          <a:xfrm>
+            <a:off x="7792083" y="2644775"/>
+            <a:ext cx="3848100" cy="3848100"/>
+          </a:xfrm>
+          <a:prstGeom prst="rect">
+            <a:avLst/>
+          </a:prstGeom>
+        </p:spPr>
+      </p:pic>
+      <p:sp>
+        <p:nvSpPr>
           <p:cNvPr id="4" name="제목 3">
             <a:extLst>
               <a:ext uri="{FF2B5EF4-FFF2-40B4-BE49-F238E27FC236}">
@@ -3936,8 +4031,8 @@
         </p:nvSpPr>
         <p:spPr>
           <a:xfrm>
-            <a:off x="1695450" y="1690688"/>
-            <a:ext cx="8839200" cy="369332"/>
+            <a:off x="1318372" y="1924844"/>
+            <a:ext cx="3423397" cy="3693319"/>
           </a:xfrm>
           <a:prstGeom prst="rect">
             <a:avLst/>
@@ -3956,26 +4051,122 @@
             </a:r>
             <a:r>
               <a:rPr lang="en-US" altLang="ko-KR" dirty="0"/>
-              <a:t>: Git</a:t>
+              <a:t>: </a:t>
+            </a:r>
+            <a:r>
+              <a:rPr lang="en-US" altLang="ko-KR" dirty="0">
+                <a:solidFill>
+                  <a:schemeClr val="accent2"/>
+                </a:solidFill>
+              </a:rPr>
+              <a:t>Git</a:t>
             </a:r>
             <a:r>
               <a:rPr lang="ko-KR" altLang="en-US" dirty="0"/>
               <a:t> </a:t>
             </a:r>
             <a:r>
+              <a:rPr lang="en-US" altLang="ko-KR" dirty="0">
+                <a:solidFill>
+                  <a:schemeClr val="accent2"/>
+                </a:solidFill>
+              </a:rPr>
+              <a:t>roadmap</a:t>
+            </a:r>
+          </a:p>
+          <a:p>
+            <a:endParaRPr lang="en-US" altLang="ko-KR" dirty="0"/>
+          </a:p>
+          <a:p>
+            <a:r>
+              <a:rPr lang="ko-KR" altLang="en-US" dirty="0"/>
+              <a:t>사용한 </a:t>
+            </a:r>
+            <a:r>
               <a:rPr lang="en-US" altLang="ko-KR" dirty="0"/>
-              <a:t>roadmap</a:t>
-            </a:r>
+              <a:t>Convention</a:t>
+            </a:r>
+          </a:p>
+          <a:p>
+            <a:endParaRPr lang="en-US" altLang="ko-KR" dirty="0"/>
+          </a:p>
+          <a:p>
+            <a:r>
+              <a:rPr lang="ko-KR" altLang="en-US" dirty="0"/>
+              <a:t>작업 방법 및 툴 소개</a:t>
+            </a:r>
+          </a:p>
+          <a:p>
             <a:endParaRPr lang="ko-KR" altLang="en-US" dirty="0"/>
           </a:p>
-        </p:txBody>
-      </p:sp>
-      <p:sp>
-        <p:nvSpPr>
-          <p:cNvPr id="6" name="TextBox 5">
-            <a:extLst>
-              <a:ext uri="{FF2B5EF4-FFF2-40B4-BE49-F238E27FC236}">
-                <a16:creationId xmlns:a16="http://schemas.microsoft.com/office/drawing/2014/main" id="{E6CA49E3-6F3E-48BF-B9F2-1BC19BFF37D4}"/>
+          <a:p>
+            <a:r>
+              <a:rPr lang="en-US" altLang="ko-KR" dirty="0">
+                <a:solidFill>
+                  <a:schemeClr val="accent2"/>
+                </a:solidFill>
+              </a:rPr>
+              <a:t>Git roadmap </a:t>
+            </a:r>
+            <a:r>
+              <a:rPr lang="ko-KR" altLang="en-US" dirty="0"/>
+              <a:t>특징</a:t>
+            </a:r>
+            <a:endParaRPr lang="en-US" altLang="ko-KR" dirty="0"/>
+          </a:p>
+          <a:p>
+            <a:endParaRPr lang="en-US" altLang="ko-KR" dirty="0"/>
+          </a:p>
+          <a:p>
+            <a:r>
+              <a:rPr lang="ko-KR" altLang="en-US" dirty="0"/>
+              <a:t>내용</a:t>
+            </a:r>
+            <a:r>
+              <a:rPr lang="en-US" altLang="ko-KR" dirty="0"/>
+              <a:t> </a:t>
+            </a:r>
+            <a:r>
+              <a:rPr lang="ko-KR" altLang="en-US" dirty="0"/>
+              <a:t>설명</a:t>
+            </a:r>
+            <a:endParaRPr lang="en-US" altLang="ko-KR" dirty="0"/>
+          </a:p>
+          <a:p>
+            <a:endParaRPr lang="en-US" altLang="ko-KR" dirty="0"/>
+          </a:p>
+          <a:p>
+            <a:r>
+              <a:rPr lang="ko-KR" altLang="en-US" dirty="0"/>
+              <a:t>앞으로의 프로젝트 방향</a:t>
+            </a:r>
+            <a:endParaRPr lang="en-US" altLang="ko-KR" dirty="0"/>
+          </a:p>
+          <a:p>
+            <a:endParaRPr lang="en-US" altLang="ko-KR" dirty="0"/>
+          </a:p>
+          <a:p>
+            <a:r>
+              <a:rPr lang="ko-KR" altLang="en-US" dirty="0"/>
+              <a:t>각자 배운 점</a:t>
+            </a:r>
+            <a:r>
+              <a:rPr lang="en-US" altLang="ko-KR" dirty="0"/>
+              <a:t>, </a:t>
+            </a:r>
+            <a:r>
+              <a:rPr lang="ko-KR" altLang="en-US" dirty="0"/>
+              <a:t>아쉬운 점</a:t>
+            </a:r>
+          </a:p>
+        </p:txBody>
+      </p:sp>
+      <p:sp>
+        <p:nvSpPr>
+          <p:cNvPr id="11" name="TextBox 10">
+            <a:extLst>
+              <a:ext uri="{FF2B5EF4-FFF2-40B4-BE49-F238E27FC236}">
+                <a16:creationId xmlns:a16="http://schemas.microsoft.com/office/drawing/2014/main" id="{D1DEAC83-B881-4177-BC7B-E77808B6D8BB}"/>
               </a:ext>
             </a:extLst>
           </p:cNvPr>
@@ -3984,8 +4175,8 @@
         </p:nvSpPr>
         <p:spPr>
           <a:xfrm>
-            <a:off x="1695450" y="2452688"/>
-            <a:ext cx="8839200" cy="369332"/>
+            <a:off x="6096000" y="1093847"/>
+            <a:ext cx="4621452" cy="5355312"/>
           </a:xfrm>
           <a:prstGeom prst="rect">
             <a:avLst/>
@@ -3998,17 +4189,1186 @@
           </a:bodyPr>
           <a:lstStyle/>
           <a:p>
+            <a:pPr marL="285750" indent="-285750">
+              <a:buFontTx/>
+              <a:buChar char="-"/>
+            </a:pPr>
+            <a:r>
+              <a:rPr lang="en-US" altLang="ko-KR" dirty="0"/>
+              <a:t>Convention </a:t>
+            </a:r>
             <a:r>
               <a:rPr lang="ko-KR" altLang="en-US" dirty="0"/>
-              <a:t>팀에서 정한 컨벤션</a:t>
-            </a:r>
-          </a:p>
-        </p:txBody>
-      </p:sp>
+              <a:t>소개</a:t>
+            </a:r>
+            <a:endParaRPr lang="en-US" altLang="ko-KR" dirty="0"/>
+          </a:p>
+          <a:p>
+            <a:pPr marL="285750" indent="-285750">
+              <a:buFontTx/>
+              <a:buChar char="-"/>
+            </a:pPr>
+            <a:r>
+              <a:rPr lang="en-US" altLang="ko-KR" dirty="0"/>
+              <a:t>Convention</a:t>
+            </a:r>
+            <a:r>
+              <a:rPr lang="ko-KR" altLang="en-US" dirty="0"/>
+              <a:t>을 사용한 이유</a:t>
+            </a:r>
+            <a:endParaRPr lang="en-US" altLang="ko-KR" dirty="0"/>
+          </a:p>
+          <a:p>
+            <a:pPr marL="285750" indent="-285750">
+              <a:buFontTx/>
+              <a:buChar char="-"/>
+            </a:pPr>
+            <a:r>
+              <a:rPr lang="ko-KR" altLang="en-US" dirty="0"/>
+              <a:t>사용 예시</a:t>
+            </a:r>
+            <a:endParaRPr lang="en-US" altLang="ko-KR" dirty="0"/>
+          </a:p>
+          <a:p>
+            <a:endParaRPr lang="en-US" altLang="ko-KR" dirty="0"/>
+          </a:p>
+          <a:p>
+            <a:endParaRPr lang="en-US" altLang="ko-KR" dirty="0"/>
+          </a:p>
+          <a:p>
+            <a:pPr marL="285750" indent="-285750">
+              <a:buFontTx/>
+              <a:buChar char="-"/>
+            </a:pPr>
+            <a:r>
+              <a:rPr lang="en-US" altLang="ko-KR" dirty="0"/>
+              <a:t>Git , </a:t>
+            </a:r>
+            <a:r>
+              <a:rPr lang="en-US" altLang="ko-KR" dirty="0" err="1"/>
+              <a:t>Sourcetree</a:t>
+            </a:r>
+            <a:r>
+              <a:rPr lang="en-US" altLang="ko-KR" dirty="0"/>
+              <a:t>, </a:t>
+            </a:r>
+            <a:r>
+              <a:rPr lang="en-US" altLang="ko-KR" dirty="0" err="1"/>
+              <a:t>github</a:t>
+            </a:r>
+            <a:r>
+              <a:rPr lang="en-US" altLang="ko-KR" dirty="0"/>
+              <a:t>, Vim, </a:t>
+            </a:r>
+            <a:r>
+              <a:rPr lang="en-US" altLang="ko-KR" dirty="0" err="1"/>
+              <a:t>Vscode</a:t>
+            </a:r>
+            <a:endParaRPr lang="en-US" altLang="ko-KR" dirty="0"/>
+          </a:p>
+          <a:p>
+            <a:pPr marL="285750" indent="-285750">
+              <a:buFontTx/>
+              <a:buChar char="-"/>
+            </a:pPr>
+            <a:r>
+              <a:rPr lang="ko-KR" altLang="en-US" dirty="0"/>
+              <a:t>논의 방식 </a:t>
+            </a:r>
+            <a:r>
+              <a:rPr lang="en-US" altLang="ko-KR" dirty="0"/>
+              <a:t>: Zoom, </a:t>
+            </a:r>
+            <a:r>
+              <a:rPr lang="en-US" altLang="ko-KR" dirty="0" err="1"/>
+              <a:t>Kakaotalk</a:t>
+            </a:r>
+            <a:endParaRPr lang="en-US" altLang="ko-KR" dirty="0"/>
+          </a:p>
+          <a:p>
+            <a:endParaRPr lang="en-US" altLang="ko-KR" dirty="0"/>
+          </a:p>
+          <a:p>
+            <a:endParaRPr lang="en-US" altLang="ko-KR" dirty="0"/>
+          </a:p>
+          <a:p>
+            <a:pPr marL="285750" indent="-285750">
+              <a:buFontTx/>
+              <a:buChar char="-"/>
+            </a:pPr>
+            <a:r>
+              <a:rPr lang="ko-KR" altLang="en-US" dirty="0"/>
+              <a:t>사용한 오픈소스 </a:t>
+            </a:r>
+            <a:r>
+              <a:rPr lang="en-US" altLang="ko-KR" dirty="0"/>
+              <a:t>Web</a:t>
+            </a:r>
+            <a:r>
+              <a:rPr lang="ko-KR" altLang="en-US" dirty="0"/>
+              <a:t> </a:t>
+            </a:r>
+            <a:r>
+              <a:rPr lang="en-US" altLang="ko-KR" dirty="0"/>
+              <a:t>skills</a:t>
+            </a:r>
+          </a:p>
+          <a:p>
+            <a:pPr marL="285750" indent="-285750">
+              <a:buFontTx/>
+              <a:buChar char="-"/>
+            </a:pPr>
+            <a:r>
+              <a:rPr lang="ko-KR" altLang="en-US" dirty="0"/>
+              <a:t>편집한 부분</a:t>
+            </a:r>
+          </a:p>
+          <a:p>
+            <a:endParaRPr lang="en-US" altLang="ko-KR" dirty="0"/>
+          </a:p>
+          <a:p>
+            <a:endParaRPr lang="en-US" altLang="ko-KR" dirty="0"/>
+          </a:p>
+          <a:p>
+            <a:pPr marL="285750" indent="-285750">
+              <a:buFontTx/>
+              <a:buChar char="-"/>
+            </a:pPr>
+            <a:r>
+              <a:rPr lang="en-US" altLang="ko-KR" dirty="0"/>
+              <a:t>Foundation</a:t>
+            </a:r>
+          </a:p>
+          <a:p>
+            <a:pPr marL="285750" indent="-285750">
+              <a:buFontTx/>
+              <a:buChar char="-"/>
+            </a:pPr>
+            <a:r>
+              <a:rPr lang="en-US" altLang="ko-KR" dirty="0"/>
+              <a:t>Git command</a:t>
+            </a:r>
+          </a:p>
+          <a:p>
+            <a:pPr marL="285750" indent="-285750">
+              <a:buFontTx/>
+              <a:buChar char="-"/>
+            </a:pPr>
+            <a:r>
+              <a:rPr lang="en-US" altLang="ko-KR" dirty="0"/>
+              <a:t>Branches</a:t>
+            </a:r>
+          </a:p>
+          <a:p>
+            <a:pPr marL="285750" indent="-285750">
+              <a:buFontTx/>
+              <a:buChar char="-"/>
+            </a:pPr>
+            <a:endParaRPr lang="en-US" altLang="ko-KR" dirty="0"/>
+          </a:p>
+          <a:p>
+            <a:pPr marL="285750" indent="-285750">
+              <a:buFontTx/>
+              <a:buChar char="-"/>
+            </a:pPr>
+            <a:r>
+              <a:rPr lang="en-US" altLang="ko-KR" dirty="0"/>
+              <a:t>SNS</a:t>
+            </a:r>
+            <a:r>
+              <a:rPr lang="ko-KR" altLang="en-US" dirty="0"/>
+              <a:t>를 이용한 제 </a:t>
+            </a:r>
+            <a:r>
+              <a:rPr lang="en-US" altLang="ko-KR" dirty="0"/>
+              <a:t>3</a:t>
+            </a:r>
+            <a:r>
+              <a:rPr lang="ko-KR" altLang="en-US" dirty="0"/>
+              <a:t>자 기여 홍보</a:t>
+            </a:r>
+            <a:endParaRPr lang="en-US" altLang="ko-KR" dirty="0"/>
+          </a:p>
+          <a:p>
+            <a:pPr marL="285750" indent="-285750">
+              <a:buFontTx/>
+              <a:buChar char="-"/>
+            </a:pPr>
+            <a:r>
+              <a:rPr lang="ko-KR" altLang="en-US" dirty="0"/>
+              <a:t>더 추가하고 싶은 내용</a:t>
+            </a:r>
+            <a:endParaRPr lang="en-US" altLang="ko-KR" dirty="0"/>
+          </a:p>
+        </p:txBody>
+      </p:sp>
+      <p:cxnSp>
+        <p:nvCxnSpPr>
+          <p:cNvPr id="3" name="직선 화살표 연결선 2">
+            <a:extLst>
+              <a:ext uri="{FF2B5EF4-FFF2-40B4-BE49-F238E27FC236}">
+                <a16:creationId xmlns:a16="http://schemas.microsoft.com/office/drawing/2014/main" id="{E2D8CC1B-1A11-4470-B43F-A3DA7BF1254F}"/>
+              </a:ext>
+            </a:extLst>
+          </p:cNvPr>
+          <p:cNvCxnSpPr>
+            <a:cxnSpLocks/>
+          </p:cNvCxnSpPr>
+          <p:nvPr/>
+        </p:nvCxnSpPr>
+        <p:spPr>
+          <a:xfrm flipV="1">
+            <a:off x="3590925" y="1690690"/>
+            <a:ext cx="2505075" cy="919160"/>
+          </a:xfrm>
+          <a:prstGeom prst="straightConnector1">
+            <a:avLst/>
+          </a:prstGeom>
+          <a:ln w="63500">
+            <a:solidFill>
+              <a:schemeClr val="accent2"/>
+            </a:solidFill>
+            <a:tailEnd type="triangle"/>
+          </a:ln>
+        </p:spPr>
+        <p:style>
+          <a:lnRef idx="1">
+            <a:schemeClr val="accent1"/>
+          </a:lnRef>
+          <a:fillRef idx="0">
+            <a:schemeClr val="accent1"/>
+          </a:fillRef>
+          <a:effectRef idx="0">
+            <a:schemeClr val="accent1"/>
+          </a:effectRef>
+          <a:fontRef idx="minor">
+            <a:schemeClr val="tx1"/>
+          </a:fontRef>
+        </p:style>
+      </p:cxnSp>
+      <p:cxnSp>
+        <p:nvCxnSpPr>
+          <p:cNvPr id="13" name="직선 화살표 연결선 12">
+            <a:extLst>
+              <a:ext uri="{FF2B5EF4-FFF2-40B4-BE49-F238E27FC236}">
+                <a16:creationId xmlns:a16="http://schemas.microsoft.com/office/drawing/2014/main" id="{039BB6F4-2B35-45F4-9EBB-3585CEC226F5}"/>
+              </a:ext>
+            </a:extLst>
+          </p:cNvPr>
+          <p:cNvCxnSpPr>
+            <a:cxnSpLocks/>
+          </p:cNvCxnSpPr>
+          <p:nvPr/>
+        </p:nvCxnSpPr>
+        <p:spPr>
+          <a:xfrm flipV="1">
+            <a:off x="3676650" y="2800351"/>
+            <a:ext cx="2419350" cy="380999"/>
+          </a:xfrm>
+          <a:prstGeom prst="straightConnector1">
+            <a:avLst/>
+          </a:prstGeom>
+          <a:ln w="63500">
+            <a:solidFill>
+              <a:schemeClr val="accent2"/>
+            </a:solidFill>
+            <a:tailEnd type="triangle"/>
+          </a:ln>
+        </p:spPr>
+        <p:style>
+          <a:lnRef idx="1">
+            <a:schemeClr val="accent1"/>
+          </a:lnRef>
+          <a:fillRef idx="0">
+            <a:schemeClr val="accent1"/>
+          </a:fillRef>
+          <a:effectRef idx="0">
+            <a:schemeClr val="accent1"/>
+          </a:effectRef>
+          <a:fontRef idx="minor">
+            <a:schemeClr val="tx1"/>
+          </a:fontRef>
+        </p:style>
+      </p:cxnSp>
+      <p:cxnSp>
+        <p:nvCxnSpPr>
+          <p:cNvPr id="15" name="직선 화살표 연결선 14">
+            <a:extLst>
+              <a:ext uri="{FF2B5EF4-FFF2-40B4-BE49-F238E27FC236}">
+                <a16:creationId xmlns:a16="http://schemas.microsoft.com/office/drawing/2014/main" id="{6E89D54C-53D0-47B2-8D1E-F3D28A04FBF5}"/>
+              </a:ext>
+            </a:extLst>
+          </p:cNvPr>
+          <p:cNvCxnSpPr>
+            <a:cxnSpLocks/>
+          </p:cNvCxnSpPr>
+          <p:nvPr/>
+        </p:nvCxnSpPr>
+        <p:spPr>
+          <a:xfrm>
+            <a:off x="3390900" y="3781425"/>
+            <a:ext cx="2705100" cy="67469"/>
+          </a:xfrm>
+          <a:prstGeom prst="straightConnector1">
+            <a:avLst/>
+          </a:prstGeom>
+          <a:ln w="63500">
+            <a:solidFill>
+              <a:schemeClr val="accent2"/>
+            </a:solidFill>
+            <a:tailEnd type="triangle"/>
+          </a:ln>
+        </p:spPr>
+        <p:style>
+          <a:lnRef idx="1">
+            <a:schemeClr val="accent1"/>
+          </a:lnRef>
+          <a:fillRef idx="0">
+            <a:schemeClr val="accent1"/>
+          </a:fillRef>
+          <a:effectRef idx="0">
+            <a:schemeClr val="accent1"/>
+          </a:effectRef>
+          <a:fontRef idx="minor">
+            <a:schemeClr val="tx1"/>
+          </a:fontRef>
+        </p:style>
+      </p:cxnSp>
+      <p:cxnSp>
+        <p:nvCxnSpPr>
+          <p:cNvPr id="17" name="직선 화살표 연결선 16">
+            <a:extLst>
+              <a:ext uri="{FF2B5EF4-FFF2-40B4-BE49-F238E27FC236}">
+                <a16:creationId xmlns:a16="http://schemas.microsoft.com/office/drawing/2014/main" id="{D879482A-FF93-4F28-A80D-55DD154AD698}"/>
+              </a:ext>
+            </a:extLst>
+          </p:cNvPr>
+          <p:cNvCxnSpPr>
+            <a:cxnSpLocks/>
+          </p:cNvCxnSpPr>
+          <p:nvPr/>
+        </p:nvCxnSpPr>
+        <p:spPr>
+          <a:xfrm>
+            <a:off x="3676650" y="4267200"/>
+            <a:ext cx="2419350" cy="900111"/>
+          </a:xfrm>
+          <a:prstGeom prst="straightConnector1">
+            <a:avLst/>
+          </a:prstGeom>
+          <a:ln w="63500">
+            <a:solidFill>
+              <a:schemeClr val="accent2"/>
+            </a:solidFill>
+            <a:tailEnd type="triangle"/>
+          </a:ln>
+        </p:spPr>
+        <p:style>
+          <a:lnRef idx="1">
+            <a:schemeClr val="accent1"/>
+          </a:lnRef>
+          <a:fillRef idx="0">
+            <a:schemeClr val="accent1"/>
+          </a:fillRef>
+          <a:effectRef idx="0">
+            <a:schemeClr val="accent1"/>
+          </a:effectRef>
+          <a:fontRef idx="minor">
+            <a:schemeClr val="tx1"/>
+          </a:fontRef>
+        </p:style>
+      </p:cxnSp>
+      <p:cxnSp>
+        <p:nvCxnSpPr>
+          <p:cNvPr id="19" name="직선 화살표 연결선 18">
+            <a:extLst>
+              <a:ext uri="{FF2B5EF4-FFF2-40B4-BE49-F238E27FC236}">
+                <a16:creationId xmlns:a16="http://schemas.microsoft.com/office/drawing/2014/main" id="{7F3C469B-BEAD-4CFD-9276-3F5BAA553293}"/>
+              </a:ext>
+            </a:extLst>
+          </p:cNvPr>
+          <p:cNvCxnSpPr>
+            <a:cxnSpLocks/>
+          </p:cNvCxnSpPr>
+          <p:nvPr/>
+        </p:nvCxnSpPr>
+        <p:spPr>
+          <a:xfrm>
+            <a:off x="3981450" y="4914900"/>
+            <a:ext cx="2114550" cy="1152525"/>
+          </a:xfrm>
+          <a:prstGeom prst="straightConnector1">
+            <a:avLst/>
+          </a:prstGeom>
+          <a:ln w="63500">
+            <a:solidFill>
+              <a:schemeClr val="accent2"/>
+            </a:solidFill>
+            <a:tailEnd type="triangle"/>
+          </a:ln>
+        </p:spPr>
+        <p:style>
+          <a:lnRef idx="1">
+            <a:schemeClr val="accent1"/>
+          </a:lnRef>
+          <a:fillRef idx="0">
+            <a:schemeClr val="accent1"/>
+          </a:fillRef>
+          <a:effectRef idx="0">
+            <a:schemeClr val="accent1"/>
+          </a:effectRef>
+          <a:fontRef idx="minor">
+            <a:schemeClr val="tx1"/>
+          </a:fontRef>
+        </p:style>
+      </p:cxnSp>
     </p:spTree>
     <p:extLst>
       <p:ext uri="{BB962C8B-B14F-4D97-AF65-F5344CB8AC3E}">
         <p14:creationId xmlns:p14="http://schemas.microsoft.com/office/powerpoint/2010/main" val="773417237"/>
+      </p:ext>
+    </p:extLst>
+  </p:cSld>
+  <p:clrMapOvr>
+    <a:masterClrMapping/>
+  </p:clrMapOvr>
+</p:sld>
+</file>
+
+<file path=ppt/slides/slide3.xml><?xml version="1.0" encoding="utf-8"?>
+<p:sld xmlns:a="http://schemas.openxmlformats.org/drawingml/2006/main" xmlns:r="http://schemas.openxmlformats.org/officeDocument/2006/relationships" xmlns:p="http://schemas.openxmlformats.org/presentationml/2006/main">
+  <p:cSld>
+    <p:spTree>
+      <p:nvGrpSpPr>
+        <p:cNvPr id="1" name=""/>
+        <p:cNvGrpSpPr/>
+        <p:nvPr/>
+      </p:nvGrpSpPr>
+      <p:grpSpPr>
+        <a:xfrm>
+          <a:off x="0" y="0"/>
+          <a:ext cx="0" cy="0"/>
+          <a:chOff x="0" y="0"/>
+          <a:chExt cx="0" cy="0"/>
+        </a:xfrm>
+      </p:grpSpPr>
+      <p:sp>
+        <p:nvSpPr>
+          <p:cNvPr id="2" name="제목 1">
+            <a:extLst>
+              <a:ext uri="{FF2B5EF4-FFF2-40B4-BE49-F238E27FC236}">
+                <a16:creationId xmlns:a16="http://schemas.microsoft.com/office/drawing/2014/main" id="{6E4ECBBC-3FEC-49DA-8671-6D9A3E7BC350}"/>
+              </a:ext>
+            </a:extLst>
+          </p:cNvPr>
+          <p:cNvSpPr>
+            <a:spLocks noGrp="1"/>
+          </p:cNvSpPr>
+          <p:nvPr>
+            <p:ph type="title"/>
+          </p:nvPr>
+        </p:nvSpPr>
+        <p:spPr/>
+        <p:txBody>
+          <a:bodyPr/>
+          <a:lstStyle/>
+          <a:p>
+            <a:r>
+              <a:rPr lang="en-US" altLang="ko-KR" dirty="0"/>
+              <a:t>Git roadmap</a:t>
+            </a:r>
+            <a:endParaRPr lang="ko-KR" altLang="en-US" dirty="0"/>
+          </a:p>
+        </p:txBody>
+      </p:sp>
+      <p:pic>
+        <p:nvPicPr>
+          <p:cNvPr id="8" name="그래픽 7">
+            <a:extLst>
+              <a:ext uri="{FF2B5EF4-FFF2-40B4-BE49-F238E27FC236}">
+                <a16:creationId xmlns:a16="http://schemas.microsoft.com/office/drawing/2014/main" id="{4FB8635D-5D3D-4349-80CC-DEFD07A42514}"/>
+              </a:ext>
+            </a:extLst>
+          </p:cNvPr>
+          <p:cNvPicPr>
+            <a:picLocks noChangeAspect="1"/>
+          </p:cNvPicPr>
+          <p:nvPr/>
+        </p:nvPicPr>
+        <p:blipFill>
+          <a:blip r:embed="rId2">
+            <a:extLst>
+              <a:ext uri="{28A0092B-C50C-407E-A947-70E740481C1C}">
+                <a14:useLocalDpi xmlns:a14="http://schemas.microsoft.com/office/drawing/2010/main" val="0"/>
+              </a:ext>
+              <a:ext uri="{96DAC541-7B7A-43D3-8B79-37D633B846F1}">
+                <asvg:svgBlip xmlns:asvg="http://schemas.microsoft.com/office/drawing/2016/SVG/main" r:embed="rId3"/>
+              </a:ext>
+            </a:extLst>
+          </a:blip>
+          <a:stretch>
+            <a:fillRect/>
+          </a:stretch>
+        </p:blipFill>
+        <p:spPr>
+          <a:xfrm>
+            <a:off x="0" y="2585563"/>
+            <a:ext cx="2937174" cy="2937174"/>
+          </a:xfrm>
+          <a:prstGeom prst="rect">
+            <a:avLst/>
+          </a:prstGeom>
+        </p:spPr>
+      </p:pic>
+      <p:pic>
+        <p:nvPicPr>
+          <p:cNvPr id="10" name="그림 9">
+            <a:extLst>
+              <a:ext uri="{FF2B5EF4-FFF2-40B4-BE49-F238E27FC236}">
+                <a16:creationId xmlns:a16="http://schemas.microsoft.com/office/drawing/2014/main" id="{CC87AA26-51FB-426F-9698-E9CFBCC97508}"/>
+              </a:ext>
+            </a:extLst>
+          </p:cNvPr>
+          <p:cNvPicPr>
+            <a:picLocks noChangeAspect="1"/>
+          </p:cNvPicPr>
+          <p:nvPr/>
+        </p:nvPicPr>
+        <p:blipFill>
+          <a:blip r:embed="rId4">
+            <a:extLst>
+              <a:ext uri="{28A0092B-C50C-407E-A947-70E740481C1C}">
+                <a14:useLocalDpi xmlns:a14="http://schemas.microsoft.com/office/drawing/2010/main" val="0"/>
+              </a:ext>
+            </a:extLst>
+          </a:blip>
+          <a:stretch>
+            <a:fillRect/>
+          </a:stretch>
+        </p:blipFill>
+        <p:spPr>
+          <a:xfrm>
+            <a:off x="3152748" y="2010196"/>
+            <a:ext cx="8776252" cy="4076502"/>
+          </a:xfrm>
+          <a:prstGeom prst="rect">
+            <a:avLst/>
+          </a:prstGeom>
+        </p:spPr>
+      </p:pic>
+    </p:spTree>
+    <p:extLst>
+      <p:ext uri="{BB962C8B-B14F-4D97-AF65-F5344CB8AC3E}">
+        <p14:creationId xmlns:p14="http://schemas.microsoft.com/office/powerpoint/2010/main" val="1900895217"/>
+      </p:ext>
+    </p:extLst>
+  </p:cSld>
+  <p:clrMapOvr>
+    <a:masterClrMapping/>
+  </p:clrMapOvr>
+</p:sld>
+</file>
+
+<file path=ppt/slides/slide4.xml><?xml version="1.0" encoding="utf-8"?>
+<p:sld xmlns:a="http://schemas.openxmlformats.org/drawingml/2006/main" xmlns:r="http://schemas.openxmlformats.org/officeDocument/2006/relationships" xmlns:p="http://schemas.openxmlformats.org/presentationml/2006/main">
+  <p:cSld>
+    <p:spTree>
+      <p:nvGrpSpPr>
+        <p:cNvPr id="1" name=""/>
+        <p:cNvGrpSpPr/>
+        <p:nvPr/>
+      </p:nvGrpSpPr>
+      <p:grpSpPr>
+        <a:xfrm>
+          <a:off x="0" y="0"/>
+          <a:ext cx="0" cy="0"/>
+          <a:chOff x="0" y="0"/>
+          <a:chExt cx="0" cy="0"/>
+        </a:xfrm>
+      </p:grpSpPr>
+      <p:sp>
+        <p:nvSpPr>
+          <p:cNvPr id="26" name="사각형: 둥근 모서리 25">
+            <a:extLst>
+              <a:ext uri="{FF2B5EF4-FFF2-40B4-BE49-F238E27FC236}">
+                <a16:creationId xmlns:a16="http://schemas.microsoft.com/office/drawing/2014/main" id="{CF44A3D4-08D3-45B5-A539-65DF16B50193}"/>
+              </a:ext>
+            </a:extLst>
+          </p:cNvPr>
+          <p:cNvSpPr/>
+          <p:nvPr/>
+        </p:nvSpPr>
+        <p:spPr>
+          <a:xfrm>
+            <a:off x="3576918" y="89647"/>
+            <a:ext cx="8364070" cy="4787153"/>
+          </a:xfrm>
+          <a:prstGeom prst="roundRect">
+            <a:avLst/>
+          </a:prstGeom>
+          <a:solidFill>
+            <a:schemeClr val="bg1"/>
+          </a:solidFill>
+          <a:ln>
+            <a:noFill/>
+          </a:ln>
+        </p:spPr>
+        <p:style>
+          <a:lnRef idx="2">
+            <a:schemeClr val="accent1">
+              <a:shade val="50000"/>
+            </a:schemeClr>
+          </a:lnRef>
+          <a:fillRef idx="1">
+            <a:schemeClr val="accent1"/>
+          </a:fillRef>
+          <a:effectRef idx="0">
+            <a:schemeClr val="accent1"/>
+          </a:effectRef>
+          <a:fontRef idx="minor">
+            <a:schemeClr val="lt1"/>
+          </a:fontRef>
+        </p:style>
+        <p:txBody>
+          <a:bodyPr rtlCol="0" anchor="ctr"/>
+          <a:lstStyle/>
+          <a:p>
+            <a:pPr algn="ctr"/>
+            <a:endParaRPr lang="ko-KR" altLang="en-US"/>
+          </a:p>
+        </p:txBody>
+      </p:sp>
+      <p:sp>
+        <p:nvSpPr>
+          <p:cNvPr id="5" name="TextBox 4">
+            <a:extLst>
+              <a:ext uri="{FF2B5EF4-FFF2-40B4-BE49-F238E27FC236}">
+                <a16:creationId xmlns:a16="http://schemas.microsoft.com/office/drawing/2014/main" id="{44092B83-1ADE-454A-891D-80170A3E8D69}"/>
+              </a:ext>
+            </a:extLst>
+          </p:cNvPr>
+          <p:cNvSpPr txBox="1"/>
+          <p:nvPr/>
+        </p:nvSpPr>
+        <p:spPr>
+          <a:xfrm>
+            <a:off x="301848" y="5143487"/>
+            <a:ext cx="6887135" cy="1231106"/>
+          </a:xfrm>
+          <a:prstGeom prst="rect">
+            <a:avLst/>
+          </a:prstGeom>
+          <a:noFill/>
+        </p:spPr>
+        <p:txBody>
+          <a:bodyPr wrap="square" rtlCol="0">
+            <a:spAutoFit/>
+          </a:bodyPr>
+          <a:lstStyle/>
+          <a:p>
+            <a:r>
+              <a:rPr lang="ko-KR" altLang="en-US" dirty="0">
+                <a:latin typeface="Britannic Bold" panose="020B0903060703020204" pitchFamily="34" charset="0"/>
+              </a:rPr>
+              <a:t>프로젝트를 개발하게 된 이유</a:t>
+            </a:r>
+            <a:r>
+              <a:rPr lang="en-US" altLang="ko-KR" dirty="0">
+                <a:latin typeface="Britannic Bold" panose="020B0903060703020204" pitchFamily="34" charset="0"/>
+              </a:rPr>
+              <a:t>?</a:t>
+            </a:r>
+            <a:r>
+              <a:rPr lang="ko-KR" altLang="en-US" sz="1400" dirty="0">
+                <a:solidFill>
+                  <a:schemeClr val="accent2"/>
+                </a:solidFill>
+                <a:latin typeface="Britannic Bold" panose="020B0903060703020204" pitchFamily="34" charset="0"/>
+              </a:rPr>
+              <a:t> </a:t>
+            </a:r>
+            <a:endParaRPr lang="en-US" altLang="ko-KR" sz="1400" dirty="0">
+              <a:solidFill>
+                <a:schemeClr val="accent2"/>
+              </a:solidFill>
+              <a:latin typeface="Britannic Bold" panose="020B0903060703020204" pitchFamily="34" charset="0"/>
+            </a:endParaRPr>
+          </a:p>
+          <a:p>
+            <a:r>
+              <a:rPr lang="ko-KR" altLang="en-US" sz="1400" dirty="0">
+                <a:solidFill>
+                  <a:schemeClr val="accent2"/>
+                </a:solidFill>
+                <a:latin typeface="Britannic Bold" panose="020B0903060703020204" pitchFamily="34" charset="0"/>
+              </a:rPr>
+              <a:t>이전부터 깃을 다루는 것에 관심이 있었고</a:t>
+            </a:r>
+            <a:r>
+              <a:rPr lang="en-US" altLang="ko-KR" sz="1400" dirty="0">
+                <a:solidFill>
+                  <a:schemeClr val="accent2"/>
+                </a:solidFill>
+                <a:latin typeface="Britannic Bold" panose="020B0903060703020204" pitchFamily="34" charset="0"/>
+              </a:rPr>
+              <a:t>, </a:t>
+            </a:r>
+            <a:r>
+              <a:rPr lang="ko-KR" altLang="en-US" sz="1400" dirty="0">
+                <a:solidFill>
+                  <a:schemeClr val="accent2"/>
+                </a:solidFill>
+                <a:latin typeface="Britannic Bold" panose="020B0903060703020204" pitchFamily="34" charset="0"/>
+              </a:rPr>
+              <a:t>버전 관리 기술의 원리를 알고 싶었습니다</a:t>
+            </a:r>
+            <a:r>
+              <a:rPr lang="en-US" altLang="ko-KR" sz="1400" dirty="0">
+                <a:solidFill>
+                  <a:schemeClr val="accent2"/>
+                </a:solidFill>
+                <a:latin typeface="Britannic Bold" panose="020B0903060703020204" pitchFamily="34" charset="0"/>
+              </a:rPr>
+              <a:t>.</a:t>
+            </a:r>
+          </a:p>
+          <a:p>
+            <a:r>
+              <a:rPr lang="ko-KR" altLang="en-US" sz="1400" dirty="0">
+                <a:solidFill>
+                  <a:schemeClr val="accent2"/>
+                </a:solidFill>
+                <a:latin typeface="Britannic Bold" panose="020B0903060703020204" pitchFamily="34" charset="0"/>
+              </a:rPr>
+              <a:t>하지만 입문자는 뭘 찾아야 하는지</a:t>
+            </a:r>
+            <a:r>
+              <a:rPr lang="en-US" altLang="ko-KR" sz="1400" dirty="0">
+                <a:solidFill>
+                  <a:schemeClr val="accent2"/>
+                </a:solidFill>
+                <a:latin typeface="Britannic Bold" panose="020B0903060703020204" pitchFamily="34" charset="0"/>
+              </a:rPr>
+              <a:t>, </a:t>
+            </a:r>
+            <a:r>
+              <a:rPr lang="ko-KR" altLang="en-US" sz="1400" dirty="0">
+                <a:solidFill>
+                  <a:schemeClr val="accent2"/>
+                </a:solidFill>
+                <a:latin typeface="Britannic Bold" panose="020B0903060703020204" pitchFamily="34" charset="0"/>
+              </a:rPr>
+              <a:t>좋은 자료가 무엇인지 모르는 경우가 많습니다</a:t>
+            </a:r>
+            <a:r>
+              <a:rPr lang="en-US" altLang="ko-KR" sz="1400" dirty="0">
+                <a:solidFill>
+                  <a:schemeClr val="accent2"/>
+                </a:solidFill>
+                <a:latin typeface="Britannic Bold" panose="020B0903060703020204" pitchFamily="34" charset="0"/>
+              </a:rPr>
+              <a:t>. </a:t>
+            </a:r>
+            <a:r>
+              <a:rPr lang="ko-KR" altLang="en-US" sz="1400" dirty="0">
+                <a:solidFill>
+                  <a:schemeClr val="accent2"/>
+                </a:solidFill>
+                <a:latin typeface="Britannic Bold" panose="020B0903060703020204" pitchFamily="34" charset="0"/>
+              </a:rPr>
+              <a:t>그래서 좋은 자료를 모아 놓고 정리해 놓은 사이트가 있다면 좋겠다고 상상했습니다</a:t>
+            </a:r>
+            <a:r>
+              <a:rPr lang="en-US" altLang="ko-KR" sz="1400" dirty="0">
+                <a:solidFill>
+                  <a:schemeClr val="accent2"/>
+                </a:solidFill>
+                <a:latin typeface="Britannic Bold" panose="020B0903060703020204" pitchFamily="34" charset="0"/>
+              </a:rPr>
+              <a:t>. </a:t>
+            </a:r>
+            <a:r>
+              <a:rPr lang="ko-KR" altLang="en-US" sz="1400" dirty="0">
+                <a:solidFill>
+                  <a:schemeClr val="accent2"/>
+                </a:solidFill>
+                <a:latin typeface="Britannic Bold" panose="020B0903060703020204" pitchFamily="34" charset="0"/>
+              </a:rPr>
+              <a:t>강사님과</a:t>
+            </a:r>
+            <a:r>
+              <a:rPr lang="en-US" altLang="ko-KR" sz="1400" dirty="0">
+                <a:solidFill>
+                  <a:schemeClr val="accent2"/>
+                </a:solidFill>
+                <a:latin typeface="Britannic Bold" panose="020B0903060703020204" pitchFamily="34" charset="0"/>
+              </a:rPr>
+              <a:t> </a:t>
+            </a:r>
+            <a:r>
+              <a:rPr lang="ko-KR" altLang="en-US" sz="1400" dirty="0">
+                <a:solidFill>
+                  <a:schemeClr val="accent2"/>
+                </a:solidFill>
+                <a:latin typeface="Britannic Bold" panose="020B0903060703020204" pitchFamily="34" charset="0"/>
+              </a:rPr>
+              <a:t>팀원들도 아이디어에 공감하여 이 프로젝트를 제작하게 되었습니다</a:t>
+            </a:r>
+            <a:r>
+              <a:rPr lang="en-US" altLang="ko-KR" sz="1400" dirty="0">
+                <a:solidFill>
+                  <a:schemeClr val="accent2"/>
+                </a:solidFill>
+                <a:latin typeface="Britannic Bold" panose="020B0903060703020204" pitchFamily="34" charset="0"/>
+              </a:rPr>
+              <a:t>.</a:t>
+            </a:r>
+            <a:endParaRPr lang="ko-KR" altLang="en-US" sz="1400" dirty="0">
+              <a:solidFill>
+                <a:schemeClr val="accent2"/>
+              </a:solidFill>
+              <a:latin typeface="Britannic Bold" panose="020B0903060703020204" pitchFamily="34" charset="0"/>
+            </a:endParaRPr>
+          </a:p>
+        </p:txBody>
+      </p:sp>
+      <p:pic>
+        <p:nvPicPr>
+          <p:cNvPr id="13" name="그림 12">
+            <a:extLst>
+              <a:ext uri="{FF2B5EF4-FFF2-40B4-BE49-F238E27FC236}">
+                <a16:creationId xmlns:a16="http://schemas.microsoft.com/office/drawing/2014/main" id="{63B57282-D8C2-4CC8-A6FF-458B2AFF6728}"/>
+              </a:ext>
+            </a:extLst>
+          </p:cNvPr>
+          <p:cNvPicPr>
+            <a:picLocks noChangeAspect="1"/>
+          </p:cNvPicPr>
+          <p:nvPr/>
+        </p:nvPicPr>
+        <p:blipFill>
+          <a:blip r:embed="rId2">
+            <a:extLst>
+              <a:ext uri="{28A0092B-C50C-407E-A947-70E740481C1C}">
+                <a14:useLocalDpi xmlns:a14="http://schemas.microsoft.com/office/drawing/2010/main" val="0"/>
+              </a:ext>
+            </a:extLst>
+          </a:blip>
+          <a:stretch>
+            <a:fillRect/>
+          </a:stretch>
+        </p:blipFill>
+        <p:spPr>
+          <a:xfrm>
+            <a:off x="2775446" y="1674"/>
+            <a:ext cx="9416553" cy="5294226"/>
+          </a:xfrm>
+          <a:prstGeom prst="rect">
+            <a:avLst/>
+          </a:prstGeom>
+        </p:spPr>
+      </p:pic>
+      <p:pic>
+        <p:nvPicPr>
+          <p:cNvPr id="15" name="그래픽 14">
+            <a:extLst>
+              <a:ext uri="{FF2B5EF4-FFF2-40B4-BE49-F238E27FC236}">
+                <a16:creationId xmlns:a16="http://schemas.microsoft.com/office/drawing/2014/main" id="{1AB57BB9-B27A-4293-A7FE-CBE37E3DF0B9}"/>
+              </a:ext>
+            </a:extLst>
+          </p:cNvPr>
+          <p:cNvPicPr>
+            <a:picLocks noChangeAspect="1"/>
+          </p:cNvPicPr>
+          <p:nvPr/>
+        </p:nvPicPr>
+        <p:blipFill>
+          <a:blip r:embed="rId3">
+            <a:extLst>
+              <a:ext uri="{28A0092B-C50C-407E-A947-70E740481C1C}">
+                <a14:useLocalDpi xmlns:a14="http://schemas.microsoft.com/office/drawing/2010/main" val="0"/>
+              </a:ext>
+              <a:ext uri="{96DAC541-7B7A-43D3-8B79-37D633B846F1}">
+                <asvg:svgBlip xmlns:asvg="http://schemas.microsoft.com/office/drawing/2016/SVG/main" r:embed="rId4"/>
+              </a:ext>
+            </a:extLst>
+          </a:blip>
+          <a:stretch>
+            <a:fillRect/>
+          </a:stretch>
+        </p:blipFill>
+        <p:spPr>
+          <a:xfrm>
+            <a:off x="9596299" y="3342638"/>
+            <a:ext cx="695324" cy="695324"/>
+          </a:xfrm>
+          <a:prstGeom prst="rect">
+            <a:avLst/>
+          </a:prstGeom>
+        </p:spPr>
+      </p:pic>
+      <p:pic>
+        <p:nvPicPr>
+          <p:cNvPr id="17" name="그래픽 16">
+            <a:extLst>
+              <a:ext uri="{FF2B5EF4-FFF2-40B4-BE49-F238E27FC236}">
+                <a16:creationId xmlns:a16="http://schemas.microsoft.com/office/drawing/2014/main" id="{6E0318CA-CA43-468E-9AB2-F3909A07411F}"/>
+              </a:ext>
+            </a:extLst>
+          </p:cNvPr>
+          <p:cNvPicPr>
+            <a:picLocks noChangeAspect="1"/>
+          </p:cNvPicPr>
+          <p:nvPr/>
+        </p:nvPicPr>
+        <p:blipFill>
+          <a:blip r:embed="rId5">
+            <a:extLst>
+              <a:ext uri="{28A0092B-C50C-407E-A947-70E740481C1C}">
+                <a14:useLocalDpi xmlns:a14="http://schemas.microsoft.com/office/drawing/2010/main" val="0"/>
+              </a:ext>
+              <a:ext uri="{96DAC541-7B7A-43D3-8B79-37D633B846F1}">
+                <asvg:svgBlip xmlns:asvg="http://schemas.microsoft.com/office/drawing/2016/SVG/main" r:embed="rId6"/>
+              </a:ext>
+            </a:extLst>
+          </a:blip>
+          <a:stretch>
+            <a:fillRect/>
+          </a:stretch>
+        </p:blipFill>
+        <p:spPr>
+          <a:xfrm>
+            <a:off x="6657975" y="2781300"/>
+            <a:ext cx="695325" cy="695325"/>
+          </a:xfrm>
+          <a:prstGeom prst="rect">
+            <a:avLst/>
+          </a:prstGeom>
+        </p:spPr>
+      </p:pic>
+      <p:pic>
+        <p:nvPicPr>
+          <p:cNvPr id="19" name="그래픽 18">
+            <a:extLst>
+              <a:ext uri="{FF2B5EF4-FFF2-40B4-BE49-F238E27FC236}">
+                <a16:creationId xmlns:a16="http://schemas.microsoft.com/office/drawing/2014/main" id="{162F667D-8BDC-4A51-AA20-044322F58413}"/>
+              </a:ext>
+            </a:extLst>
+          </p:cNvPr>
+          <p:cNvPicPr>
+            <a:picLocks noChangeAspect="1"/>
+          </p:cNvPicPr>
+          <p:nvPr/>
+        </p:nvPicPr>
+        <p:blipFill>
+          <a:blip r:embed="rId7">
+            <a:extLst>
+              <a:ext uri="{28A0092B-C50C-407E-A947-70E740481C1C}">
+                <a14:useLocalDpi xmlns:a14="http://schemas.microsoft.com/office/drawing/2010/main" val="0"/>
+              </a:ext>
+              <a:ext uri="{96DAC541-7B7A-43D3-8B79-37D633B846F1}">
+                <asvg:svgBlip xmlns:asvg="http://schemas.microsoft.com/office/drawing/2016/SVG/main" r:embed="rId8"/>
+              </a:ext>
+            </a:extLst>
+          </a:blip>
+          <a:stretch>
+            <a:fillRect/>
+          </a:stretch>
+        </p:blipFill>
+        <p:spPr>
+          <a:xfrm>
+            <a:off x="9596299" y="2123437"/>
+            <a:ext cx="695324" cy="696602"/>
+          </a:xfrm>
+          <a:prstGeom prst="rect">
+            <a:avLst/>
+          </a:prstGeom>
+        </p:spPr>
+      </p:pic>
+      <p:pic>
+        <p:nvPicPr>
+          <p:cNvPr id="21" name="그래픽 20">
+            <a:extLst>
+              <a:ext uri="{FF2B5EF4-FFF2-40B4-BE49-F238E27FC236}">
+                <a16:creationId xmlns:a16="http://schemas.microsoft.com/office/drawing/2014/main" id="{32FDEF3D-6420-41C0-B0E3-E8BD577FB678}"/>
+              </a:ext>
+            </a:extLst>
+          </p:cNvPr>
+          <p:cNvPicPr>
+            <a:picLocks noChangeAspect="1"/>
+          </p:cNvPicPr>
+          <p:nvPr/>
+        </p:nvPicPr>
+        <p:blipFill>
+          <a:blip r:embed="rId9">
+            <a:extLst>
+              <a:ext uri="{28A0092B-C50C-407E-A947-70E740481C1C}">
+                <a14:useLocalDpi xmlns:a14="http://schemas.microsoft.com/office/drawing/2010/main" val="0"/>
+              </a:ext>
+              <a:ext uri="{96DAC541-7B7A-43D3-8B79-37D633B846F1}">
+                <asvg:svgBlip xmlns:asvg="http://schemas.microsoft.com/office/drawing/2016/SVG/main" r:embed="rId10"/>
+              </a:ext>
+            </a:extLst>
+          </a:blip>
+          <a:stretch>
+            <a:fillRect/>
+          </a:stretch>
+        </p:blipFill>
+        <p:spPr>
+          <a:xfrm>
+            <a:off x="8441659" y="2190750"/>
+            <a:ext cx="561975" cy="561975"/>
+          </a:xfrm>
+          <a:prstGeom prst="rect">
+            <a:avLst/>
+          </a:prstGeom>
+        </p:spPr>
+      </p:pic>
+      <p:pic>
+        <p:nvPicPr>
+          <p:cNvPr id="23" name="그래픽 22">
+            <a:extLst>
+              <a:ext uri="{FF2B5EF4-FFF2-40B4-BE49-F238E27FC236}">
+                <a16:creationId xmlns:a16="http://schemas.microsoft.com/office/drawing/2014/main" id="{52400A7B-83CC-4D5F-AF9A-99C548B798F5}"/>
+              </a:ext>
+            </a:extLst>
+          </p:cNvPr>
+          <p:cNvPicPr>
+            <a:picLocks noChangeAspect="1"/>
+          </p:cNvPicPr>
+          <p:nvPr/>
+        </p:nvPicPr>
+        <p:blipFill>
+          <a:blip r:embed="rId11">
+            <a:extLst>
+              <a:ext uri="{28A0092B-C50C-407E-A947-70E740481C1C}">
+                <a14:useLocalDpi xmlns:a14="http://schemas.microsoft.com/office/drawing/2010/main" val="0"/>
+              </a:ext>
+              <a:ext uri="{96DAC541-7B7A-43D3-8B79-37D633B846F1}">
+                <asvg:svgBlip xmlns:asvg="http://schemas.microsoft.com/office/drawing/2016/SVG/main" r:embed="rId12"/>
+              </a:ext>
+            </a:extLst>
+          </a:blip>
+          <a:stretch>
+            <a:fillRect/>
+          </a:stretch>
+        </p:blipFill>
+        <p:spPr>
+          <a:xfrm>
+            <a:off x="7889209" y="1123950"/>
+            <a:ext cx="685800" cy="685800"/>
+          </a:xfrm>
+          <a:prstGeom prst="rect">
+            <a:avLst/>
+          </a:prstGeom>
+        </p:spPr>
+      </p:pic>
+      <p:pic>
+        <p:nvPicPr>
+          <p:cNvPr id="25" name="그래픽 24">
+            <a:extLst>
+              <a:ext uri="{FF2B5EF4-FFF2-40B4-BE49-F238E27FC236}">
+                <a16:creationId xmlns:a16="http://schemas.microsoft.com/office/drawing/2014/main" id="{FDA95303-01D4-4428-B9D9-3E46D83B04A0}"/>
+              </a:ext>
+            </a:extLst>
+          </p:cNvPr>
+          <p:cNvPicPr>
+            <a:picLocks noChangeAspect="1"/>
+          </p:cNvPicPr>
+          <p:nvPr/>
+        </p:nvPicPr>
+        <p:blipFill>
+          <a:blip r:embed="rId13">
+            <a:extLst>
+              <a:ext uri="{28A0092B-C50C-407E-A947-70E740481C1C}">
+                <a14:useLocalDpi xmlns:a14="http://schemas.microsoft.com/office/drawing/2010/main" val="0"/>
+              </a:ext>
+              <a:ext uri="{96DAC541-7B7A-43D3-8B79-37D633B846F1}">
+                <asvg:svgBlip xmlns:asvg="http://schemas.microsoft.com/office/drawing/2016/SVG/main" r:embed="rId14"/>
+              </a:ext>
+            </a:extLst>
+          </a:blip>
+          <a:stretch>
+            <a:fillRect/>
+          </a:stretch>
+        </p:blipFill>
+        <p:spPr>
+          <a:xfrm>
+            <a:off x="6541283" y="1670460"/>
+            <a:ext cx="647700" cy="647700"/>
+          </a:xfrm>
+          <a:prstGeom prst="rect">
+            <a:avLst/>
+          </a:prstGeom>
+        </p:spPr>
+      </p:pic>
+    </p:spTree>
+    <p:extLst>
+      <p:ext uri="{BB962C8B-B14F-4D97-AF65-F5344CB8AC3E}">
+        <p14:creationId xmlns:p14="http://schemas.microsoft.com/office/powerpoint/2010/main" val="1409357129"/>
+      </p:ext>
+    </p:extLst>
+  </p:cSld>
+  <p:clrMapOvr>
+    <a:masterClrMapping/>
+  </p:clrMapOvr>
+</p:sld>
+</file>
+
+<file path=ppt/slides/slide5.xml><?xml version="1.0" encoding="utf-8"?>
+<p:sld xmlns:a="http://schemas.openxmlformats.org/drawingml/2006/main" xmlns:r="http://schemas.openxmlformats.org/officeDocument/2006/relationships" xmlns:p="http://schemas.openxmlformats.org/presentationml/2006/main">
+  <p:cSld>
+    <p:spTree>
+      <p:nvGrpSpPr>
+        <p:cNvPr id="1" name=""/>
+        <p:cNvGrpSpPr/>
+        <p:nvPr/>
+      </p:nvGrpSpPr>
+      <p:grpSpPr>
+        <a:xfrm>
+          <a:off x="0" y="0"/>
+          <a:ext cx="0" cy="0"/>
+          <a:chOff x="0" y="0"/>
+          <a:chExt cx="0" cy="0"/>
+        </a:xfrm>
+      </p:grpSpPr>
+      <p:sp>
+        <p:nvSpPr>
+          <p:cNvPr id="2" name="제목 1">
+            <a:extLst>
+              <a:ext uri="{FF2B5EF4-FFF2-40B4-BE49-F238E27FC236}">
+                <a16:creationId xmlns:a16="http://schemas.microsoft.com/office/drawing/2014/main" id="{B03CC3A5-0517-4FDD-8F49-085DB56C8D10}"/>
+              </a:ext>
+            </a:extLst>
+          </p:cNvPr>
+          <p:cNvSpPr>
+            <a:spLocks noGrp="1"/>
+          </p:cNvSpPr>
+          <p:nvPr>
+            <p:ph type="title"/>
+          </p:nvPr>
+        </p:nvSpPr>
+        <p:spPr/>
+        <p:txBody>
+          <a:bodyPr/>
+          <a:lstStyle/>
+          <a:p>
+            <a:r>
+              <a:rPr lang="ko-KR" altLang="en-US" dirty="0"/>
+              <a:t>사용한 </a:t>
+            </a:r>
+            <a:r>
+              <a:rPr lang="en-US" altLang="ko-KR" dirty="0"/>
+              <a:t>Convention</a:t>
+            </a:r>
+            <a:endParaRPr lang="ko-KR" altLang="en-US" dirty="0"/>
+          </a:p>
+        </p:txBody>
+      </p:sp>
+    </p:spTree>
+    <p:extLst>
+      <p:ext uri="{BB962C8B-B14F-4D97-AF65-F5344CB8AC3E}">
+        <p14:creationId xmlns:p14="http://schemas.microsoft.com/office/powerpoint/2010/main" val="3699128274"/>
       </p:ext>
     </p:extLst>
   </p:cSld>
@@ -4303,7 +5663,40 @@
       </a:bgFillStyleLst>
     </a:fmtScheme>
   </a:themeElements>
-  <a:objectDefaults/>
+  <a:objectDefaults>
+    <a:spDef>
+      <a:spPr>
+        <a:solidFill>
+          <a:schemeClr val="bg1"/>
+        </a:solidFill>
+        <a:ln>
+          <a:noFill/>
+        </a:ln>
+      </a:spPr>
+      <a:bodyPr rtlCol="0" anchor="ctr"/>
+      <a:lstStyle>
+        <a:defPPr algn="ctr">
+          <a:defRPr/>
+        </a:defPPr>
+      </a:lstStyle>
+      <a:style>
+        <a:lnRef idx="2">
+          <a:schemeClr val="accent1">
+            <a:shade val="50000"/>
+          </a:schemeClr>
+        </a:lnRef>
+        <a:fillRef idx="1">
+          <a:schemeClr val="accent1"/>
+        </a:fillRef>
+        <a:effectRef idx="0">
+          <a:schemeClr val="accent1"/>
+        </a:effectRef>
+        <a:fontRef idx="minor">
+          <a:schemeClr val="lt1"/>
+        </a:fontRef>
+      </a:style>
+    </a:spDef>
+  </a:objectDefaults>
   <a:extraClrSchemeLst/>
   <a:extLst>
     <a:ext uri="{05A4C25C-085E-4340-85A3-A5531E510DB2}">

</xml_diff>